<commit_message>
Fix: replaced synthetic mock data with actual assigned Bluestock dataset, rebuilt full pipeline
</commit_message>
<xml_diff>
--- a/reports/Bluestock_MF_Presentation.pptx
+++ b/reports/Bluestock_MF_Presentation.pptx
@@ -3972,7 +3972,7 @@
               </a:defRPr>
             </a:pPr>
             <a:r>
-              <a:t>▸  F001 (Bluestock Large Cap): #1 fund — CAGR 47.8%, Sharpe 0.775</a:t>
+              <a:t>▸  The top equity large-cap fund: #1 fund — CAGR 8.9%, Sharpe 7.680</a:t>
             </a:r>
           </a:p>
           <a:p>
@@ -4134,7 +4134,7 @@
               </a:defRPr>
             </a:pPr>
             <a:r>
-              <a:t>▸  Increase marketing spend on F001 — clear performance leader</a:t>
+              <a:t>▸  Increase marketing spend on top fund — clear performance leader</a:t>
             </a:r>
           </a:p>
           <a:p>
@@ -4179,7 +4179,7 @@
               </a:defRPr>
             </a:pPr>
             <a:r>
-              <a:t>▸  Review F009 (Apex Balanced): –17.35% 1Y CAGR in 2025</a:t>
+              <a:t>▸  Review underperforming funds with negative CAGR</a:t>
             </a:r>
           </a:p>
           <a:p>
@@ -8254,7 +8254,7 @@
                   <a:srgbClr val="10B981"/>
                 </a:solidFill>
               </a:rPr>
-              <a:t>Total AUM: ₹257,038 Cr  |  SIP Inflows: ₹8.0 Cr  |  50K Transactions</a:t>
+              <a:t>Total AUM: ₹6,274,000 Cr  |  SIP Inflows: ₹0.0 Cr  |  50K Transactions</a:t>
             </a:r>
           </a:p>
         </p:txBody>
@@ -8376,7 +8376,7 @@
                   <a:srgbClr val="0B1F4B"/>
                 </a:solidFill>
               </a:rPr>
-              <a:t>₹2.6L Cr</a:t>
+              <a:t>₹62.7L Cr</a:t>
             </a:r>
           </a:p>
         </p:txBody>
@@ -8532,7 +8532,7 @@
                   <a:srgbClr val="0B1F4B"/>
                 </a:solidFill>
               </a:rPr>
-              <a:t>₹8.0 Cr</a:t>
+              <a:t>₹0.0 Cr</a:t>
             </a:r>
           </a:p>
         </p:txBody>
@@ -9522,7 +9522,7 @@
                   <a:srgbClr val="10B981"/>
                 </a:solidFill>
               </a:rPr>
-              <a:t>Top Fund: Bluestock Large Cap Fund  |  CAGR 1Y: 47.8%  |  Sharpe: 0.775</a:t>
+              <a:t>Top Fund: ICICI Pru Liquid Fund - Regular - Growth  |  CAGR 1Y: 8.9%  |  Sharpe: 7.680</a:t>
             </a:r>
           </a:p>
         </p:txBody>
@@ -10196,7 +10196,7 @@
                   <a:srgbClr val="1E293B"/>
                 </a:solidFill>
               </a:rPr>
-              <a:t>F001</a:t>
+              <a:t>120507</a:t>
             </a:r>
           </a:p>
         </p:txBody>
@@ -10230,7 +10230,7 @@
                   <a:srgbClr val="1E293B"/>
                 </a:solidFill>
               </a:rPr>
-              <a:t>Bluestock Large Cap </a:t>
+              <a:t>ICICI Pru Liquid Fun..</a:t>
             </a:r>
           </a:p>
         </p:txBody>
@@ -10264,7 +10264,7 @@
                   <a:srgbClr val="1E293B"/>
                 </a:solidFill>
               </a:rPr>
-              <a:t>47.8</a:t>
+              <a:t>8.9%</a:t>
             </a:r>
           </a:p>
         </p:txBody>
@@ -10298,7 +10298,7 @@
                   <a:srgbClr val="1E293B"/>
                 </a:solidFill>
               </a:rPr>
-              <a:t>0.775</a:t>
+              <a:t>7.68</a:t>
             </a:r>
           </a:p>
         </p:txBody>
@@ -10332,7 +10332,7 @@
                   <a:srgbClr val="1E293B"/>
                 </a:solidFill>
               </a:rPr>
-              <a:t>-27.3</a:t>
+              <a:t>-2.6%</a:t>
             </a:r>
           </a:p>
         </p:txBody>
@@ -10366,7 +10366,7 @@
                   <a:srgbClr val="1E293B"/>
                 </a:solidFill>
               </a:rPr>
-              <a:t>9.70</a:t>
+              <a:t>29.30</a:t>
             </a:r>
           </a:p>
         </p:txBody>
@@ -10477,7 +10477,7 @@
                   <a:srgbClr val="1E293B"/>
                 </a:solidFill>
               </a:rPr>
-              <a:t>F007</a:t>
+              <a:t>148567</a:t>
             </a:r>
           </a:p>
         </p:txBody>
@@ -10511,7 +10511,7 @@
                   <a:srgbClr val="1E293B"/>
                 </a:solidFill>
               </a:rPr>
-              <a:t>Horizon Bluechip Fun</a:t>
+              <a:t>Mirae Asset Large Ca..</a:t>
             </a:r>
           </a:p>
         </p:txBody>
@@ -10545,7 +10545,7 @@
                   <a:srgbClr val="1E293B"/>
                 </a:solidFill>
               </a:rPr>
-              <a:t>36.3</a:t>
+              <a:t>15.1%</a:t>
             </a:r>
           </a:p>
         </p:txBody>
@@ -10579,7 +10579,7 @@
                   <a:srgbClr val="1E293B"/>
                 </a:solidFill>
               </a:rPr>
-              <a:t>0.484</a:t>
+              <a:t>1.06</a:t>
             </a:r>
           </a:p>
         </p:txBody>
@@ -10613,7 +10613,7 @@
                   <a:srgbClr val="1E293B"/>
                 </a:solidFill>
               </a:rPr>
-              <a:t>-30.6</a:t>
+              <a:t>-17.1%</a:t>
             </a:r>
           </a:p>
         </p:txBody>
@@ -10647,7 +10647,7 @@
                   <a:srgbClr val="1E293B"/>
                 </a:solidFill>
               </a:rPr>
-              <a:t>8.45</a:t>
+              <a:t>28.70</a:t>
             </a:r>
           </a:p>
         </p:txBody>
@@ -10758,7 +10758,7 @@
                   <a:srgbClr val="1E293B"/>
                 </a:solidFill>
               </a:rPr>
-              <a:t>F003</a:t>
+              <a:t>120843</a:t>
             </a:r>
           </a:p>
         </p:txBody>
@@ -10792,7 +10792,7 @@
                   <a:srgbClr val="1E293B"/>
                 </a:solidFill>
               </a:rPr>
-              <a:t>Bluestock Flexi Cap </a:t>
+              <a:t>Kotak Flexicap Fund ..</a:t>
             </a:r>
           </a:p>
         </p:txBody>
@@ -10826,7 +10826,7 @@
                   <a:srgbClr val="1E293B"/>
                 </a:solidFill>
               </a:rPr>
-              <a:t>17.1</a:t>
+              <a:t>15.7%</a:t>
             </a:r>
           </a:p>
         </p:txBody>
@@ -10860,7 +10860,7 @@
                   <a:srgbClr val="1E293B"/>
                 </a:solidFill>
               </a:rPr>
-              <a:t>0.341</a:t>
+              <a:t>0.98</a:t>
             </a:r>
           </a:p>
         </p:txBody>
@@ -10894,7 +10894,7 @@
                   <a:srgbClr val="1E293B"/>
                 </a:solidFill>
               </a:rPr>
-              <a:t>-35.3</a:t>
+              <a:t>-19.5%</a:t>
             </a:r>
           </a:p>
         </p:txBody>
@@ -10928,7 +10928,7 @@
                   <a:srgbClr val="1E293B"/>
                 </a:solidFill>
               </a:rPr>
-              <a:t>7.75</a:t>
+              <a:t>28.65</a:t>
             </a:r>
           </a:p>
         </p:txBody>
@@ -11039,7 +11039,7 @@
                   <a:srgbClr val="1E293B"/>
                 </a:solidFill>
               </a:rPr>
-              <a:t>F002</a:t>
+              <a:t>102887</a:t>
             </a:r>
           </a:p>
         </p:txBody>
@@ -11073,7 +11073,7 @@
                   <a:srgbClr val="1E293B"/>
                 </a:solidFill>
               </a:rPr>
-              <a:t>Bluestock Mid Cap Op</a:t>
+              <a:t>UTI Flexi Cap Fund -..</a:t>
             </a:r>
           </a:p>
         </p:txBody>
@@ -11107,7 +11107,7 @@
                   <a:srgbClr val="1E293B"/>
                 </a:solidFill>
               </a:rPr>
-              <a:t>7.3</a:t>
+              <a:t>17.4%</a:t>
             </a:r>
           </a:p>
         </p:txBody>
@@ -11141,7 +11141,7 @@
                   <a:srgbClr val="1E293B"/>
                 </a:solidFill>
               </a:rPr>
-              <a:t>0.625</a:t>
+              <a:t>0.96</a:t>
             </a:r>
           </a:p>
         </p:txBody>
@@ -11175,7 +11175,7 @@
                   <a:srgbClr val="1E293B"/>
                 </a:solidFill>
               </a:rPr>
-              <a:t>-19.5</a:t>
+              <a:t>-12.1%</a:t>
             </a:r>
           </a:p>
         </p:txBody>
@@ -11209,7 +11209,7 @@
                   <a:srgbClr val="1E293B"/>
                 </a:solidFill>
               </a:rPr>
-              <a:t>7.05</a:t>
+              <a:t>28.45</a:t>
             </a:r>
           </a:p>
         </p:txBody>
@@ -11320,7 +11320,7 @@
                   <a:srgbClr val="1E293B"/>
                 </a:solidFill>
               </a:rPr>
-              <a:t>F008</a:t>
+              <a:t>118632</a:t>
             </a:r>
           </a:p>
         </p:txBody>
@@ -11354,7 +11354,7 @@
                   <a:srgbClr val="1E293B"/>
                 </a:solidFill>
               </a:rPr>
-              <a:t>Pinnacle Small Cap F</a:t>
+              <a:t>Nippon India Large C..</a:t>
             </a:r>
           </a:p>
         </p:txBody>
@@ -11388,7 +11388,7 @@
                   <a:srgbClr val="1E293B"/>
                 </a:solidFill>
               </a:rPr>
-              <a:t>8.7</a:t>
+              <a:t>15.8%</a:t>
             </a:r>
           </a:p>
         </p:txBody>
@@ -11422,7 +11422,7 @@
                   <a:srgbClr val="1E293B"/>
                 </a:solidFill>
               </a:rPr>
-              <a:t>0.321</a:t>
+              <a:t>1.00</a:t>
             </a:r>
           </a:p>
         </p:txBody>
@@ -11456,7 +11456,7 @@
                   <a:srgbClr val="1E293B"/>
                 </a:solidFill>
               </a:rPr>
-              <a:t>-26.3</a:t>
+              <a:t>-16.1%</a:t>
             </a:r>
           </a:p>
         </p:txBody>
@@ -11490,7 +11490,7 @@
                   <a:srgbClr val="1E293B"/>
                 </a:solidFill>
               </a:rPr>
-              <a:t>6.45</a:t>
+              <a:t>28.05</a:t>
             </a:r>
           </a:p>
         </p:txBody>
@@ -11816,7 +11816,7 @@
               </a:defRPr>
             </a:pPr>
             <a:r>
-              <a:t>▸  All equity funds show positive alpha (best: F001 = 0.2235 annualised)</a:t>
+              <a:t>▸  All equity funds show positive alpha (best: Top Fund = 1.9800 annualised)</a:t>
             </a:r>
           </a:p>
           <a:p>
@@ -11831,7 +11831,7 @@
               </a:defRPr>
             </a:pPr>
             <a:r>
-              <a:t>▸  F001 (Large Cap) and F007 (Bluechip) occupy top-right of risk/return chart: best return per unit of risk</a:t>
+              <a:t>▸  Top Large Cap funds occupy top-right of risk/return chart: best return per unit of risk</a:t>
             </a:r>
           </a:p>
           <a:p>
@@ -11846,7 +11846,7 @@
               </a:defRPr>
             </a:pPr>
             <a:r>
-              <a:t>▸  Worst max drawdown: F003 Flexi Cap at -35.3%  |  Best: F010 Gilt at -3.2%</a:t>
+              <a:t>▸  Worst max drawdown: Worst at -33.5%  |  Best: Best at -2.2%</a:t>
             </a:r>
           </a:p>
         </p:txBody>

</xml_diff>